<commit_message>
Refresh project presentation with latest BI features
Update create_ppt.py + regenerate project_presentation.pptx to cover Smart Intelligence (domain confidence + insight filtering), Power BI-grade interactive charts, KPI cross-filtering, and the one-screen Executive View across the Solution, Features, and Demo slides.

Co-authored-by: Cursor <cursoragent@cursor.com>
</commit_message>
<xml_diff>
--- a/presentation/project_presentation.pptx
+++ b/presentation/project_presentation.pptx
@@ -1143,7 +1143,7 @@
           <a:lstStyle/>
           <a:p>
             <a:r>
-              <a:t>Eight modules. The data engine cleans and types data automatically. Domain intelligence detects the vertical and reshapes KPIs. There's a KPI engine, smart visualizations, and a data-quality scorer. On the AI side: executive summary and data story, ranked business insights with recommendations, and the Data Copilot — natural-language chat, NL-to-SQL on DuckDB, and a light RAG insight engine. Plus dataset comparison, forecasting, and fully branded multi-format export.</a:t>
+              <a:t>The data engine cleans and types data automatically. A Smart Intelligence layer detects the vertical with a confidence score and filters out domain-irrelevant framing. KPIs are domain-aware, and the visuals are Tableau/Power BI-grade Plotly charts. The dashboard is interactive: click a KPI to cross-filter every chart, or flip the Executive View toggle for a single-screen summary. On the AI side: executive summary and data story, ranked business insights with recommendations, and the Data Copilot — natural-language chat, NL-to-SQL on DuckDB, and a light RAG engine — plus fully branded multi-format export.</a:t>
             </a:r>
           </a:p>
         </p:txBody>
@@ -8885,7 +8885,7 @@
         <p:spPr>
           <a:xfrm>
             <a:off x="548640" y="4297680"/>
-            <a:ext cx="11091672" cy="1691640"/>
+            <a:ext cx="11091672" cy="1874519"/>
           </a:xfrm>
           <a:prstGeom prst="roundRect">
             <a:avLst>
@@ -8925,7 +8925,7 @@
                 <a:spcPct val="100000"/>
               </a:lnSpc>
               <a:spcAft>
-                <a:spcPts val="700"/>
+                <a:spcPts val="600"/>
               </a:spcAft>
             </a:pPr>
             <a:r>
@@ -8941,33 +8941,33 @@
           <a:p>
             <a:pPr algn="l">
               <a:lnSpc>
-                <a:spcPct val="125000"/>
+                <a:spcPct val="122000"/>
               </a:lnSpc>
               <a:spcAft>
                 <a:spcPts val="300"/>
               </a:spcAft>
             </a:pPr>
             <a:r>
-              <a:rPr sz="1300" b="0" i="0">
+              <a:rPr sz="1250" b="0" i="0">
                 <a:solidFill>
                   <a:srgbClr val="ECEEF6"/>
                 </a:solidFill>
                 <a:latin typeface="Segoe UI"/>
               </a:rPr>
-              <a:t>Domain-aware:  one engine adapts KPIs, charts, personas &amp; AI focus across 10 business domains.</a:t>
+              <a:t>Domain-aware:  a Smart Intelligence layer detects your domain with a confidence score and filters out irrelevant framing.</a:t>
             </a:r>
           </a:p>
           <a:p>
             <a:pPr algn="l">
               <a:lnSpc>
-                <a:spcPct val="125000"/>
+                <a:spcPct val="122000"/>
               </a:lnSpc>
               <a:spcAft>
                 <a:spcPts val="300"/>
               </a:spcAft>
             </a:pPr>
             <a:r>
-              <a:rPr sz="1300" b="0" i="0">
+              <a:rPr sz="1250" b="0" i="0">
                 <a:solidFill>
                   <a:srgbClr val="ECEEF6"/>
                 </a:solidFill>
@@ -8979,30 +8979,49 @@
           <a:p>
             <a:pPr algn="l">
               <a:lnSpc>
-                <a:spcPct val="125000"/>
+                <a:spcPct val="122000"/>
               </a:lnSpc>
               <a:spcAft>
                 <a:spcPts val="300"/>
               </a:spcAft>
             </a:pPr>
             <a:r>
-              <a:rPr sz="1300" b="0" i="0">
+              <a:rPr sz="1250" b="0" i="0">
                 <a:solidFill>
                   <a:srgbClr val="ECEEF6"/>
                 </a:solidFill>
                 <a:latin typeface="Segoe UI"/>
               </a:rPr>
+              <a:t>Interactive BI:  Power BI-grade charts, click-a-KPI cross-filtering, and a one-screen Executive View.</a:t>
+            </a:r>
+          </a:p>
+          <a:p>
+            <a:pPr algn="l">
+              <a:lnSpc>
+                <a:spcPct val="122000"/>
+              </a:lnSpc>
+              <a:spcAft>
+                <a:spcPts val="300"/>
+              </a:spcAft>
+            </a:pPr>
+            <a:r>
+              <a:rPr sz="1250" b="0" i="0">
+                <a:solidFill>
+                  <a:srgbClr val="ECEEF6"/>
+                </a:solidFill>
+                <a:latin typeface="Segoe UI"/>
+              </a:rPr>
               <a:t>Conversational:  natural-language chat, NL→SQL on DuckDB, and a lightweight RAG insight engine.</a:t>
             </a:r>
           </a:p>
           <a:p>
             <a:pPr algn="l">
               <a:lnSpc>
-                <a:spcPct val="125000"/>
-              </a:lnSpc>
-            </a:pPr>
-            <a:r>
-              <a:rPr sz="1300" b="0" i="0">
+                <a:spcPct val="122000"/>
+              </a:lnSpc>
+            </a:pPr>
+            <a:r>
+              <a:rPr sz="1250" b="0" i="0">
                 <a:solidFill>
                   <a:srgbClr val="ECEEF6"/>
                 </a:solidFill>
@@ -13559,7 +13578,7 @@
                 </a:solidFill>
                 <a:latin typeface="Segoe UI"/>
               </a:rPr>
-              <a:t>Eight modules, one cohesive workspace</a:t>
+              <a:t>A cohesive, domain-aware BI workspace</a:t>
             </a:r>
           </a:p>
         </p:txBody>
@@ -13743,7 +13762,7 @@
                 </a:solidFill>
                 <a:latin typeface="Segoe UI"/>
               </a:rPr>
-              <a:t>Domain Intelligence — </a:t>
+              <a:t>Smart Intelligence — </a:t>
             </a:r>
             <a:r>
               <a:rPr sz="1350" b="0" i="0">
@@ -13752,7 +13771,7 @@
                 </a:solidFill>
                 <a:latin typeface="Segoe UI"/>
               </a:rPr>
-              <a:t>auto-detects 10 business domains, adapts KPIs</a:t>
+              <a:t>auto-detects 10 domains with a confidence score</a:t>
             </a:r>
           </a:p>
           <a:p>
@@ -13780,7 +13799,7 @@
                 </a:solidFill>
                 <a:latin typeface="Segoe UI"/>
               </a:rPr>
-              <a:t>KPI Engine — </a:t>
+              <a:t>Insight Filtering — </a:t>
             </a:r>
             <a:r>
               <a:rPr sz="1350" b="0" i="0">
@@ -13789,7 +13808,7 @@
                 </a:solidFill>
                 <a:latin typeface="Segoe UI"/>
               </a:rPr>
-              <a:t>domain-aware metrics with currency/% formatting &amp; deltas</a:t>
+              <a:t>drops irrelevant framing (no 'profit' on healthcare)</a:t>
             </a:r>
           </a:p>
           <a:p>
@@ -13817,7 +13836,7 @@
                 </a:solidFill>
                 <a:latin typeface="Segoe UI"/>
               </a:rPr>
-              <a:t>Smart Visuals — </a:t>
+              <a:t>KPI Engine — </a:t>
             </a:r>
             <a:r>
               <a:rPr sz="1350" b="0" i="0">
@@ -13826,7 +13845,7 @@
                 </a:solidFill>
                 <a:latin typeface="Segoe UI"/>
               </a:rPr>
-              <a:t>auto-selected Plotly charts + category breakdowns</a:t>
+              <a:t>domain-aware metrics, currency/% formatting &amp; deltas</a:t>
             </a:r>
           </a:p>
           <a:p>
@@ -13854,7 +13873,7 @@
                 </a:solidFill>
                 <a:latin typeface="Segoe UI"/>
               </a:rPr>
-              <a:t>Data Quality — </a:t>
+              <a:t>BI-Grade Visuals — </a:t>
             </a:r>
             <a:r>
               <a:rPr sz="1350" b="0" i="0">
@@ -13863,7 +13882,7 @@
                 </a:solidFill>
                 <a:latin typeface="Segoe UI"/>
               </a:rPr>
-              <a:t>0–100 score, completeness/consistency/validity</a:t>
+              <a:t>Tableau / Power BI-quality interactive Plotly charts</a:t>
             </a:r>
           </a:p>
         </p:txBody>
@@ -13914,7 +13933,7 @@
                 </a:solidFill>
                 <a:latin typeface="Segoe UI"/>
               </a:rPr>
-              <a:t>AI Summary &amp; Story — </a:t>
+              <a:t>Interactive Dashboard — </a:t>
             </a:r>
             <a:r>
               <a:rPr sz="1350" b="0" i="0">
@@ -13923,7 +13942,7 @@
                 </a:solidFill>
                 <a:latin typeface="Segoe UI"/>
               </a:rPr>
-              <a:t>executive narrative + chart-by-chart storytelling</a:t>
+              <a:t>KPI→chart cross-filter + one-screen Executive View</a:t>
             </a:r>
           </a:p>
           <a:p>
@@ -13951,7 +13970,7 @@
                 </a:solidFill>
                 <a:latin typeface="Segoe UI"/>
               </a:rPr>
-              <a:t>Business Insights — </a:t>
+              <a:t>AI Summary &amp; Story — </a:t>
             </a:r>
             <a:r>
               <a:rPr sz="1350" b="0" i="0">
@@ -13960,7 +13979,7 @@
                 </a:solidFill>
                 <a:latin typeface="Segoe UI"/>
               </a:rPr>
-              <a:t>ranked findings, severity &amp; recommendations</a:t>
+              <a:t>executive narrative + chart-by-chart storytelling</a:t>
             </a:r>
           </a:p>
           <a:p>
@@ -13988,7 +14007,7 @@
                 </a:solidFill>
                 <a:latin typeface="Segoe UI"/>
               </a:rPr>
-              <a:t>Data Copilot — </a:t>
+              <a:t>Business Insights — </a:t>
             </a:r>
             <a:r>
               <a:rPr sz="1350" b="0" i="0">
@@ -13997,7 +14016,7 @@
                 </a:solidFill>
                 <a:latin typeface="Segoe UI"/>
               </a:rPr>
-              <a:t>NL chat · NL→SQL (DuckDB) · light RAG insights</a:t>
+              <a:t>ranked findings, severity &amp; recommendations</a:t>
             </a:r>
           </a:p>
           <a:p>
@@ -14025,7 +14044,7 @@
                 </a:solidFill>
                 <a:latin typeface="Segoe UI"/>
               </a:rPr>
-              <a:t>Compare &amp; Forecast — </a:t>
+              <a:t>Data Copilot — </a:t>
             </a:r>
             <a:r>
               <a:rPr sz="1350" b="0" i="0">
@@ -14034,7 +14053,7 @@
                 </a:solidFill>
                 <a:latin typeface="Segoe UI"/>
               </a:rPr>
-              <a:t>dataset comparison + trend forecasting</a:t>
+              <a:t>NL chat · NL→SQL (DuckDB) · light RAG insights</a:t>
             </a:r>
           </a:p>
           <a:p>
@@ -15605,7 +15624,7 @@
                 </a:solidFill>
                 <a:latin typeface="Segoe UI"/>
               </a:rPr>
-              <a:t>2.  Dashboard renders KPI cards, smart charts, and a data-quality score instantly.</a:t>
+              <a:t>2.  Dashboard renders KPI cards, BI-grade charts &amp; a quality score — click a KPI to cross-filter, or flip to Executive View.</a:t>
             </a:r>
           </a:p>
           <a:p>

</xml_diff>